<commit_message>
Fig 4D volcano: "Other" sig genes recoloured to neutral grey
User feedback: highlight only the 4 pathway categories; the 206
"Other" sig genes should fade into the background. Changed:

  Other, up-good : project teal  → medium grey #6C757D
  Other, up-poor : project coral → medium grey #6C757D
  (NS cloud stays the lighter grey #C0C6CF)

Legend collapses "Other, up-good" + "Other, up-poor" into one entry
"Other (no pathway)  (n = 206)". The 22 pathway-member dots
(amber/plum/cerulean/moss) now carry all the visual emphasis against
a grey backdrop.
</commit_message>
<xml_diff>
--- a/260418_add/ppt/Fig4D_volcano_gene_pathwaycat_native_editable.pptx
+++ b/260418_add/ppt/Fig4D_volcano_gene_pathwaycat_native_editable.pptx
@@ -26796,7 +26796,7 @@
             <a:avLst/>
           </a:prstGeom>
           <a:solidFill>
-            <a:srgbClr val="C53E1F"/>
+            <a:srgbClr val="6C757D"/>
           </a:solidFill>
           <a:ln w="4445">
             <a:solidFill>
@@ -26842,7 +26842,7 @@
             <a:avLst/>
           </a:prstGeom>
           <a:solidFill>
-            <a:srgbClr val="0A7D6E"/>
+            <a:srgbClr val="6C757D"/>
           </a:solidFill>
           <a:ln w="4445">
             <a:solidFill>
@@ -26888,7 +26888,7 @@
             <a:avLst/>
           </a:prstGeom>
           <a:solidFill>
-            <a:srgbClr val="C53E1F"/>
+            <a:srgbClr val="6C757D"/>
           </a:solidFill>
           <a:ln w="4445">
             <a:solidFill>
@@ -26934,7 +26934,7 @@
             <a:avLst/>
           </a:prstGeom>
           <a:solidFill>
-            <a:srgbClr val="0A7D6E"/>
+            <a:srgbClr val="6C757D"/>
           </a:solidFill>
           <a:ln w="4445">
             <a:solidFill>
@@ -26980,7 +26980,7 @@
             <a:avLst/>
           </a:prstGeom>
           <a:solidFill>
-            <a:srgbClr val="C53E1F"/>
+            <a:srgbClr val="6C757D"/>
           </a:solidFill>
           <a:ln w="4445">
             <a:solidFill>
@@ -27026,7 +27026,7 @@
             <a:avLst/>
           </a:prstGeom>
           <a:solidFill>
-            <a:srgbClr val="0A7D6E"/>
+            <a:srgbClr val="6C757D"/>
           </a:solidFill>
           <a:ln w="4445">
             <a:solidFill>
@@ -27072,7 +27072,7 @@
             <a:avLst/>
           </a:prstGeom>
           <a:solidFill>
-            <a:srgbClr val="C53E1F"/>
+            <a:srgbClr val="6C757D"/>
           </a:solidFill>
           <a:ln w="4445">
             <a:solidFill>
@@ -27118,7 +27118,7 @@
             <a:avLst/>
           </a:prstGeom>
           <a:solidFill>
-            <a:srgbClr val="0A7D6E"/>
+            <a:srgbClr val="6C757D"/>
           </a:solidFill>
           <a:ln w="4445">
             <a:solidFill>
@@ -27164,7 +27164,7 @@
             <a:avLst/>
           </a:prstGeom>
           <a:solidFill>
-            <a:srgbClr val="0A7D6E"/>
+            <a:srgbClr val="6C757D"/>
           </a:solidFill>
           <a:ln w="4445">
             <a:solidFill>
@@ -27210,7 +27210,7 @@
             <a:avLst/>
           </a:prstGeom>
           <a:solidFill>
-            <a:srgbClr val="C53E1F"/>
+            <a:srgbClr val="6C757D"/>
           </a:solidFill>
           <a:ln w="4445">
             <a:solidFill>
@@ -27256,7 +27256,7 @@
             <a:avLst/>
           </a:prstGeom>
           <a:solidFill>
-            <a:srgbClr val="0A7D6E"/>
+            <a:srgbClr val="6C757D"/>
           </a:solidFill>
           <a:ln w="4445">
             <a:solidFill>
@@ -27302,7 +27302,7 @@
             <a:avLst/>
           </a:prstGeom>
           <a:solidFill>
-            <a:srgbClr val="C53E1F"/>
+            <a:srgbClr val="6C757D"/>
           </a:solidFill>
           <a:ln w="4445">
             <a:solidFill>
@@ -27348,7 +27348,7 @@
             <a:avLst/>
           </a:prstGeom>
           <a:solidFill>
-            <a:srgbClr val="0A7D6E"/>
+            <a:srgbClr val="6C757D"/>
           </a:solidFill>
           <a:ln w="4445">
             <a:solidFill>
@@ -27394,7 +27394,7 @@
             <a:avLst/>
           </a:prstGeom>
           <a:solidFill>
-            <a:srgbClr val="0A7D6E"/>
+            <a:srgbClr val="6C757D"/>
           </a:solidFill>
           <a:ln w="4445">
             <a:solidFill>
@@ -27440,7 +27440,7 @@
             <a:avLst/>
           </a:prstGeom>
           <a:solidFill>
-            <a:srgbClr val="C53E1F"/>
+            <a:srgbClr val="6C757D"/>
           </a:solidFill>
           <a:ln w="4445">
             <a:solidFill>
@@ -27486,7 +27486,7 @@
             <a:avLst/>
           </a:prstGeom>
           <a:solidFill>
-            <a:srgbClr val="0A7D6E"/>
+            <a:srgbClr val="6C757D"/>
           </a:solidFill>
           <a:ln w="4445">
             <a:solidFill>
@@ -27532,7 +27532,7 @@
             <a:avLst/>
           </a:prstGeom>
           <a:solidFill>
-            <a:srgbClr val="0A7D6E"/>
+            <a:srgbClr val="6C757D"/>
           </a:solidFill>
           <a:ln w="4445">
             <a:solidFill>
@@ -27578,7 +27578,7 @@
             <a:avLst/>
           </a:prstGeom>
           <a:solidFill>
-            <a:srgbClr val="0A7D6E"/>
+            <a:srgbClr val="6C757D"/>
           </a:solidFill>
           <a:ln w="4445">
             <a:solidFill>
@@ -27624,7 +27624,7 @@
             <a:avLst/>
           </a:prstGeom>
           <a:solidFill>
-            <a:srgbClr val="C53E1F"/>
+            <a:srgbClr val="6C757D"/>
           </a:solidFill>
           <a:ln w="4445">
             <a:solidFill>
@@ -27670,7 +27670,7 @@
             <a:avLst/>
           </a:prstGeom>
           <a:solidFill>
-            <a:srgbClr val="0A7D6E"/>
+            <a:srgbClr val="6C757D"/>
           </a:solidFill>
           <a:ln w="4445">
             <a:solidFill>
@@ -27716,7 +27716,7 @@
             <a:avLst/>
           </a:prstGeom>
           <a:solidFill>
-            <a:srgbClr val="0A7D6E"/>
+            <a:srgbClr val="6C757D"/>
           </a:solidFill>
           <a:ln w="4445">
             <a:solidFill>
@@ -27762,7 +27762,7 @@
             <a:avLst/>
           </a:prstGeom>
           <a:solidFill>
-            <a:srgbClr val="0A7D6E"/>
+            <a:srgbClr val="6C757D"/>
           </a:solidFill>
           <a:ln w="4445">
             <a:solidFill>
@@ -27808,7 +27808,7 @@
             <a:avLst/>
           </a:prstGeom>
           <a:solidFill>
-            <a:srgbClr val="0A7D6E"/>
+            <a:srgbClr val="6C757D"/>
           </a:solidFill>
           <a:ln w="4445">
             <a:solidFill>
@@ -27854,7 +27854,7 @@
             <a:avLst/>
           </a:prstGeom>
           <a:solidFill>
-            <a:srgbClr val="0A7D6E"/>
+            <a:srgbClr val="6C757D"/>
           </a:solidFill>
           <a:ln w="4445">
             <a:solidFill>
@@ -27900,7 +27900,7 @@
             <a:avLst/>
           </a:prstGeom>
           <a:solidFill>
-            <a:srgbClr val="C53E1F"/>
+            <a:srgbClr val="6C757D"/>
           </a:solidFill>
           <a:ln w="4445">
             <a:solidFill>
@@ -27946,7 +27946,7 @@
             <a:avLst/>
           </a:prstGeom>
           <a:solidFill>
-            <a:srgbClr val="C53E1F"/>
+            <a:srgbClr val="6C757D"/>
           </a:solidFill>
           <a:ln w="4445">
             <a:solidFill>
@@ -27992,7 +27992,7 @@
             <a:avLst/>
           </a:prstGeom>
           <a:solidFill>
-            <a:srgbClr val="0A7D6E"/>
+            <a:srgbClr val="6C757D"/>
           </a:solidFill>
           <a:ln w="4445">
             <a:solidFill>
@@ -28038,7 +28038,7 @@
             <a:avLst/>
           </a:prstGeom>
           <a:solidFill>
-            <a:srgbClr val="C53E1F"/>
+            <a:srgbClr val="6C757D"/>
           </a:solidFill>
           <a:ln w="4445">
             <a:solidFill>
@@ -28084,7 +28084,7 @@
             <a:avLst/>
           </a:prstGeom>
           <a:solidFill>
-            <a:srgbClr val="C53E1F"/>
+            <a:srgbClr val="6C757D"/>
           </a:solidFill>
           <a:ln w="4445">
             <a:solidFill>
@@ -28130,7 +28130,7 @@
             <a:avLst/>
           </a:prstGeom>
           <a:solidFill>
-            <a:srgbClr val="C53E1F"/>
+            <a:srgbClr val="6C757D"/>
           </a:solidFill>
           <a:ln w="4445">
             <a:solidFill>
@@ -28176,7 +28176,7 @@
             <a:avLst/>
           </a:prstGeom>
           <a:solidFill>
-            <a:srgbClr val="C53E1F"/>
+            <a:srgbClr val="6C757D"/>
           </a:solidFill>
           <a:ln w="4445">
             <a:solidFill>
@@ -28222,7 +28222,7 @@
             <a:avLst/>
           </a:prstGeom>
           <a:solidFill>
-            <a:srgbClr val="0A7D6E"/>
+            <a:srgbClr val="6C757D"/>
           </a:solidFill>
           <a:ln w="4445">
             <a:solidFill>
@@ -28268,7 +28268,7 @@
             <a:avLst/>
           </a:prstGeom>
           <a:solidFill>
-            <a:srgbClr val="0A7D6E"/>
+            <a:srgbClr val="6C757D"/>
           </a:solidFill>
           <a:ln w="4445">
             <a:solidFill>
@@ -28314,7 +28314,7 @@
             <a:avLst/>
           </a:prstGeom>
           <a:solidFill>
-            <a:srgbClr val="C53E1F"/>
+            <a:srgbClr val="6C757D"/>
           </a:solidFill>
           <a:ln w="4445">
             <a:solidFill>
@@ -28360,7 +28360,7 @@
             <a:avLst/>
           </a:prstGeom>
           <a:solidFill>
-            <a:srgbClr val="C53E1F"/>
+            <a:srgbClr val="6C757D"/>
           </a:solidFill>
           <a:ln w="4445">
             <a:solidFill>
@@ -28406,7 +28406,7 @@
             <a:avLst/>
           </a:prstGeom>
           <a:solidFill>
-            <a:srgbClr val="0A7D6E"/>
+            <a:srgbClr val="6C757D"/>
           </a:solidFill>
           <a:ln w="4445">
             <a:solidFill>
@@ -28452,7 +28452,7 @@
             <a:avLst/>
           </a:prstGeom>
           <a:solidFill>
-            <a:srgbClr val="0A7D6E"/>
+            <a:srgbClr val="6C757D"/>
           </a:solidFill>
           <a:ln w="4445">
             <a:solidFill>
@@ -28498,7 +28498,7 @@
             <a:avLst/>
           </a:prstGeom>
           <a:solidFill>
-            <a:srgbClr val="C53E1F"/>
+            <a:srgbClr val="6C757D"/>
           </a:solidFill>
           <a:ln w="4445">
             <a:solidFill>
@@ -28544,7 +28544,7 @@
             <a:avLst/>
           </a:prstGeom>
           <a:solidFill>
-            <a:srgbClr val="C53E1F"/>
+            <a:srgbClr val="6C757D"/>
           </a:solidFill>
           <a:ln w="4445">
             <a:solidFill>
@@ -28590,7 +28590,7 @@
             <a:avLst/>
           </a:prstGeom>
           <a:solidFill>
-            <a:srgbClr val="C53E1F"/>
+            <a:srgbClr val="6C757D"/>
           </a:solidFill>
           <a:ln w="4445">
             <a:solidFill>
@@ -28636,7 +28636,7 @@
             <a:avLst/>
           </a:prstGeom>
           <a:solidFill>
-            <a:srgbClr val="0A7D6E"/>
+            <a:srgbClr val="6C757D"/>
           </a:solidFill>
           <a:ln w="4445">
             <a:solidFill>
@@ -28682,7 +28682,7 @@
             <a:avLst/>
           </a:prstGeom>
           <a:solidFill>
-            <a:srgbClr val="0A7D6E"/>
+            <a:srgbClr val="6C757D"/>
           </a:solidFill>
           <a:ln w="4445">
             <a:solidFill>
@@ -28728,7 +28728,7 @@
             <a:avLst/>
           </a:prstGeom>
           <a:solidFill>
-            <a:srgbClr val="C53E1F"/>
+            <a:srgbClr val="6C757D"/>
           </a:solidFill>
           <a:ln w="4445">
             <a:solidFill>
@@ -28774,7 +28774,7 @@
             <a:avLst/>
           </a:prstGeom>
           <a:solidFill>
-            <a:srgbClr val="C53E1F"/>
+            <a:srgbClr val="6C757D"/>
           </a:solidFill>
           <a:ln w="4445">
             <a:solidFill>
@@ -28820,7 +28820,7 @@
             <a:avLst/>
           </a:prstGeom>
           <a:solidFill>
-            <a:srgbClr val="C53E1F"/>
+            <a:srgbClr val="6C757D"/>
           </a:solidFill>
           <a:ln w="4445">
             <a:solidFill>
@@ -28866,7 +28866,7 @@
             <a:avLst/>
           </a:prstGeom>
           <a:solidFill>
-            <a:srgbClr val="C53E1F"/>
+            <a:srgbClr val="6C757D"/>
           </a:solidFill>
           <a:ln w="4445">
             <a:solidFill>
@@ -28912,7 +28912,7 @@
             <a:avLst/>
           </a:prstGeom>
           <a:solidFill>
-            <a:srgbClr val="C53E1F"/>
+            <a:srgbClr val="6C757D"/>
           </a:solidFill>
           <a:ln w="4445">
             <a:solidFill>
@@ -28958,7 +28958,7 @@
             <a:avLst/>
           </a:prstGeom>
           <a:solidFill>
-            <a:srgbClr val="C53E1F"/>
+            <a:srgbClr val="6C757D"/>
           </a:solidFill>
           <a:ln w="4445">
             <a:solidFill>
@@ -29004,7 +29004,7 @@
             <a:avLst/>
           </a:prstGeom>
           <a:solidFill>
-            <a:srgbClr val="C53E1F"/>
+            <a:srgbClr val="6C757D"/>
           </a:solidFill>
           <a:ln w="4445">
             <a:solidFill>
@@ -29050,7 +29050,7 @@
             <a:avLst/>
           </a:prstGeom>
           <a:solidFill>
-            <a:srgbClr val="0A7D6E"/>
+            <a:srgbClr val="6C757D"/>
           </a:solidFill>
           <a:ln w="4445">
             <a:solidFill>
@@ -29096,7 +29096,7 @@
             <a:avLst/>
           </a:prstGeom>
           <a:solidFill>
-            <a:srgbClr val="0A7D6E"/>
+            <a:srgbClr val="6C757D"/>
           </a:solidFill>
           <a:ln w="4445">
             <a:solidFill>
@@ -29142,7 +29142,7 @@
             <a:avLst/>
           </a:prstGeom>
           <a:solidFill>
-            <a:srgbClr val="0A7D6E"/>
+            <a:srgbClr val="6C757D"/>
           </a:solidFill>
           <a:ln w="4445">
             <a:solidFill>
@@ -29188,7 +29188,7 @@
             <a:avLst/>
           </a:prstGeom>
           <a:solidFill>
-            <a:srgbClr val="0A7D6E"/>
+            <a:srgbClr val="6C757D"/>
           </a:solidFill>
           <a:ln w="4445">
             <a:solidFill>
@@ -29234,7 +29234,7 @@
             <a:avLst/>
           </a:prstGeom>
           <a:solidFill>
-            <a:srgbClr val="C53E1F"/>
+            <a:srgbClr val="6C757D"/>
           </a:solidFill>
           <a:ln w="4445">
             <a:solidFill>
@@ -29280,7 +29280,7 @@
             <a:avLst/>
           </a:prstGeom>
           <a:solidFill>
-            <a:srgbClr val="C53E1F"/>
+            <a:srgbClr val="6C757D"/>
           </a:solidFill>
           <a:ln w="4445">
             <a:solidFill>
@@ -29326,7 +29326,7 @@
             <a:avLst/>
           </a:prstGeom>
           <a:solidFill>
-            <a:srgbClr val="C53E1F"/>
+            <a:srgbClr val="6C757D"/>
           </a:solidFill>
           <a:ln w="4445">
             <a:solidFill>
@@ -29372,7 +29372,7 @@
             <a:avLst/>
           </a:prstGeom>
           <a:solidFill>
-            <a:srgbClr val="C53E1F"/>
+            <a:srgbClr val="6C757D"/>
           </a:solidFill>
           <a:ln w="4445">
             <a:solidFill>
@@ -29418,7 +29418,7 @@
             <a:avLst/>
           </a:prstGeom>
           <a:solidFill>
-            <a:srgbClr val="0A7D6E"/>
+            <a:srgbClr val="6C757D"/>
           </a:solidFill>
           <a:ln w="4445">
             <a:solidFill>
@@ -29464,7 +29464,7 @@
             <a:avLst/>
           </a:prstGeom>
           <a:solidFill>
-            <a:srgbClr val="C53E1F"/>
+            <a:srgbClr val="6C757D"/>
           </a:solidFill>
           <a:ln w="4445">
             <a:solidFill>
@@ -29510,7 +29510,7 @@
             <a:avLst/>
           </a:prstGeom>
           <a:solidFill>
-            <a:srgbClr val="0A7D6E"/>
+            <a:srgbClr val="6C757D"/>
           </a:solidFill>
           <a:ln w="4445">
             <a:solidFill>
@@ -29556,7 +29556,7 @@
             <a:avLst/>
           </a:prstGeom>
           <a:solidFill>
-            <a:srgbClr val="0A7D6E"/>
+            <a:srgbClr val="6C757D"/>
           </a:solidFill>
           <a:ln w="4445">
             <a:solidFill>
@@ -29602,7 +29602,7 @@
             <a:avLst/>
           </a:prstGeom>
           <a:solidFill>
-            <a:srgbClr val="C53E1F"/>
+            <a:srgbClr val="6C757D"/>
           </a:solidFill>
           <a:ln w="4445">
             <a:solidFill>
@@ -29648,7 +29648,7 @@
             <a:avLst/>
           </a:prstGeom>
           <a:solidFill>
-            <a:srgbClr val="0A7D6E"/>
+            <a:srgbClr val="6C757D"/>
           </a:solidFill>
           <a:ln w="4445">
             <a:solidFill>
@@ -29694,7 +29694,7 @@
             <a:avLst/>
           </a:prstGeom>
           <a:solidFill>
-            <a:srgbClr val="0A7D6E"/>
+            <a:srgbClr val="6C757D"/>
           </a:solidFill>
           <a:ln w="4445">
             <a:solidFill>
@@ -29740,7 +29740,7 @@
             <a:avLst/>
           </a:prstGeom>
           <a:solidFill>
-            <a:srgbClr val="0A7D6E"/>
+            <a:srgbClr val="6C757D"/>
           </a:solidFill>
           <a:ln w="4445">
             <a:solidFill>
@@ -29786,7 +29786,7 @@
             <a:avLst/>
           </a:prstGeom>
           <a:solidFill>
-            <a:srgbClr val="0A7D6E"/>
+            <a:srgbClr val="6C757D"/>
           </a:solidFill>
           <a:ln w="4445">
             <a:solidFill>
@@ -29832,7 +29832,7 @@
             <a:avLst/>
           </a:prstGeom>
           <a:solidFill>
-            <a:srgbClr val="0A7D6E"/>
+            <a:srgbClr val="6C757D"/>
           </a:solidFill>
           <a:ln w="4445">
             <a:solidFill>
@@ -29878,7 +29878,7 @@
             <a:avLst/>
           </a:prstGeom>
           <a:solidFill>
-            <a:srgbClr val="C53E1F"/>
+            <a:srgbClr val="6C757D"/>
           </a:solidFill>
           <a:ln w="4445">
             <a:solidFill>
@@ -29924,7 +29924,7 @@
             <a:avLst/>
           </a:prstGeom>
           <a:solidFill>
-            <a:srgbClr val="0A7D6E"/>
+            <a:srgbClr val="6C757D"/>
           </a:solidFill>
           <a:ln w="4445">
             <a:solidFill>
@@ -29970,7 +29970,7 @@
             <a:avLst/>
           </a:prstGeom>
           <a:solidFill>
-            <a:srgbClr val="0A7D6E"/>
+            <a:srgbClr val="6C757D"/>
           </a:solidFill>
           <a:ln w="4445">
             <a:solidFill>
@@ -30016,7 +30016,7 @@
             <a:avLst/>
           </a:prstGeom>
           <a:solidFill>
-            <a:srgbClr val="C53E1F"/>
+            <a:srgbClr val="6C757D"/>
           </a:solidFill>
           <a:ln w="4445">
             <a:solidFill>
@@ -30062,7 +30062,7 @@
             <a:avLst/>
           </a:prstGeom>
           <a:solidFill>
-            <a:srgbClr val="C53E1F"/>
+            <a:srgbClr val="6C757D"/>
           </a:solidFill>
           <a:ln w="4445">
             <a:solidFill>
@@ -30108,7 +30108,7 @@
             <a:avLst/>
           </a:prstGeom>
           <a:solidFill>
-            <a:srgbClr val="0A7D6E"/>
+            <a:srgbClr val="6C757D"/>
           </a:solidFill>
           <a:ln w="4445">
             <a:solidFill>
@@ -30154,7 +30154,7 @@
             <a:avLst/>
           </a:prstGeom>
           <a:solidFill>
-            <a:srgbClr val="0A7D6E"/>
+            <a:srgbClr val="6C757D"/>
           </a:solidFill>
           <a:ln w="4445">
             <a:solidFill>
@@ -30200,7 +30200,7 @@
             <a:avLst/>
           </a:prstGeom>
           <a:solidFill>
-            <a:srgbClr val="0A7D6E"/>
+            <a:srgbClr val="6C757D"/>
           </a:solidFill>
           <a:ln w="4445">
             <a:solidFill>
@@ -30246,7 +30246,7 @@
             <a:avLst/>
           </a:prstGeom>
           <a:solidFill>
-            <a:srgbClr val="C53E1F"/>
+            <a:srgbClr val="6C757D"/>
           </a:solidFill>
           <a:ln w="4445">
             <a:solidFill>
@@ -30292,7 +30292,7 @@
             <a:avLst/>
           </a:prstGeom>
           <a:solidFill>
-            <a:srgbClr val="C53E1F"/>
+            <a:srgbClr val="6C757D"/>
           </a:solidFill>
           <a:ln w="4445">
             <a:solidFill>
@@ -30338,7 +30338,7 @@
             <a:avLst/>
           </a:prstGeom>
           <a:solidFill>
-            <a:srgbClr val="C53E1F"/>
+            <a:srgbClr val="6C757D"/>
           </a:solidFill>
           <a:ln w="4445">
             <a:solidFill>
@@ -30384,7 +30384,7 @@
             <a:avLst/>
           </a:prstGeom>
           <a:solidFill>
-            <a:srgbClr val="0A7D6E"/>
+            <a:srgbClr val="6C757D"/>
           </a:solidFill>
           <a:ln w="4445">
             <a:solidFill>
@@ -30430,7 +30430,7 @@
             <a:avLst/>
           </a:prstGeom>
           <a:solidFill>
-            <a:srgbClr val="C53E1F"/>
+            <a:srgbClr val="6C757D"/>
           </a:solidFill>
           <a:ln w="4445">
             <a:solidFill>
@@ -30476,7 +30476,7 @@
             <a:avLst/>
           </a:prstGeom>
           <a:solidFill>
-            <a:srgbClr val="C53E1F"/>
+            <a:srgbClr val="6C757D"/>
           </a:solidFill>
           <a:ln w="4445">
             <a:solidFill>
@@ -30522,7 +30522,7 @@
             <a:avLst/>
           </a:prstGeom>
           <a:solidFill>
-            <a:srgbClr val="0A7D6E"/>
+            <a:srgbClr val="6C757D"/>
           </a:solidFill>
           <a:ln w="4445">
             <a:solidFill>
@@ -30568,7 +30568,7 @@
             <a:avLst/>
           </a:prstGeom>
           <a:solidFill>
-            <a:srgbClr val="0A7D6E"/>
+            <a:srgbClr val="6C757D"/>
           </a:solidFill>
           <a:ln w="4445">
             <a:solidFill>
@@ -30614,7 +30614,7 @@
             <a:avLst/>
           </a:prstGeom>
           <a:solidFill>
-            <a:srgbClr val="C53E1F"/>
+            <a:srgbClr val="6C757D"/>
           </a:solidFill>
           <a:ln w="4445">
             <a:solidFill>
@@ -30660,7 +30660,7 @@
             <a:avLst/>
           </a:prstGeom>
           <a:solidFill>
-            <a:srgbClr val="0A7D6E"/>
+            <a:srgbClr val="6C757D"/>
           </a:solidFill>
           <a:ln w="4445">
             <a:solidFill>
@@ -30706,7 +30706,7 @@
             <a:avLst/>
           </a:prstGeom>
           <a:solidFill>
-            <a:srgbClr val="0A7D6E"/>
+            <a:srgbClr val="6C757D"/>
           </a:solidFill>
           <a:ln w="4445">
             <a:solidFill>
@@ -30752,7 +30752,7 @@
             <a:avLst/>
           </a:prstGeom>
           <a:solidFill>
-            <a:srgbClr val="C53E1F"/>
+            <a:srgbClr val="6C757D"/>
           </a:solidFill>
           <a:ln w="4445">
             <a:solidFill>
@@ -30798,7 +30798,7 @@
             <a:avLst/>
           </a:prstGeom>
           <a:solidFill>
-            <a:srgbClr val="0A7D6E"/>
+            <a:srgbClr val="6C757D"/>
           </a:solidFill>
           <a:ln w="4445">
             <a:solidFill>
@@ -30844,7 +30844,7 @@
             <a:avLst/>
           </a:prstGeom>
           <a:solidFill>
-            <a:srgbClr val="0A7D6E"/>
+            <a:srgbClr val="6C757D"/>
           </a:solidFill>
           <a:ln w="4445">
             <a:solidFill>
@@ -30890,7 +30890,7 @@
             <a:avLst/>
           </a:prstGeom>
           <a:solidFill>
-            <a:srgbClr val="C53E1F"/>
+            <a:srgbClr val="6C757D"/>
           </a:solidFill>
           <a:ln w="4445">
             <a:solidFill>
@@ -30936,7 +30936,7 @@
             <a:avLst/>
           </a:prstGeom>
           <a:solidFill>
-            <a:srgbClr val="0A7D6E"/>
+            <a:srgbClr val="6C757D"/>
           </a:solidFill>
           <a:ln w="4445">
             <a:solidFill>
@@ -30982,7 +30982,7 @@
             <a:avLst/>
           </a:prstGeom>
           <a:solidFill>
-            <a:srgbClr val="C53E1F"/>
+            <a:srgbClr val="6C757D"/>
           </a:solidFill>
           <a:ln w="4445">
             <a:solidFill>
@@ -31028,7 +31028,7 @@
             <a:avLst/>
           </a:prstGeom>
           <a:solidFill>
-            <a:srgbClr val="C53E1F"/>
+            <a:srgbClr val="6C757D"/>
           </a:solidFill>
           <a:ln w="4445">
             <a:solidFill>
@@ -31074,7 +31074,7 @@
             <a:avLst/>
           </a:prstGeom>
           <a:solidFill>
-            <a:srgbClr val="C53E1F"/>
+            <a:srgbClr val="6C757D"/>
           </a:solidFill>
           <a:ln w="4445">
             <a:solidFill>
@@ -31120,7 +31120,7 @@
             <a:avLst/>
           </a:prstGeom>
           <a:solidFill>
-            <a:srgbClr val="C53E1F"/>
+            <a:srgbClr val="6C757D"/>
           </a:solidFill>
           <a:ln w="4445">
             <a:solidFill>
@@ -31166,7 +31166,7 @@
             <a:avLst/>
           </a:prstGeom>
           <a:solidFill>
-            <a:srgbClr val="0A7D6E"/>
+            <a:srgbClr val="6C757D"/>
           </a:solidFill>
           <a:ln w="4445">
             <a:solidFill>
@@ -31212,7 +31212,7 @@
             <a:avLst/>
           </a:prstGeom>
           <a:solidFill>
-            <a:srgbClr val="0A7D6E"/>
+            <a:srgbClr val="6C757D"/>
           </a:solidFill>
           <a:ln w="4445">
             <a:solidFill>
@@ -31258,7 +31258,7 @@
             <a:avLst/>
           </a:prstGeom>
           <a:solidFill>
-            <a:srgbClr val="C53E1F"/>
+            <a:srgbClr val="6C757D"/>
           </a:solidFill>
           <a:ln w="4445">
             <a:solidFill>
@@ -31304,7 +31304,7 @@
             <a:avLst/>
           </a:prstGeom>
           <a:solidFill>
-            <a:srgbClr val="0A7D6E"/>
+            <a:srgbClr val="6C757D"/>
           </a:solidFill>
           <a:ln w="4445">
             <a:solidFill>
@@ -31350,7 +31350,7 @@
             <a:avLst/>
           </a:prstGeom>
           <a:solidFill>
-            <a:srgbClr val="0A7D6E"/>
+            <a:srgbClr val="6C757D"/>
           </a:solidFill>
           <a:ln w="4445">
             <a:solidFill>
@@ -31396,7 +31396,7 @@
             <a:avLst/>
           </a:prstGeom>
           <a:solidFill>
-            <a:srgbClr val="0A7D6E"/>
+            <a:srgbClr val="6C757D"/>
           </a:solidFill>
           <a:ln w="4445">
             <a:solidFill>
@@ -31442,7 +31442,7 @@
             <a:avLst/>
           </a:prstGeom>
           <a:solidFill>
-            <a:srgbClr val="0A7D6E"/>
+            <a:srgbClr val="6C757D"/>
           </a:solidFill>
           <a:ln w="4445">
             <a:solidFill>
@@ -31488,7 +31488,7 @@
             <a:avLst/>
           </a:prstGeom>
           <a:solidFill>
-            <a:srgbClr val="0A7D6E"/>
+            <a:srgbClr val="6C757D"/>
           </a:solidFill>
           <a:ln w="4445">
             <a:solidFill>
@@ -31534,7 +31534,7 @@
             <a:avLst/>
           </a:prstGeom>
           <a:solidFill>
-            <a:srgbClr val="C53E1F"/>
+            <a:srgbClr val="6C757D"/>
           </a:solidFill>
           <a:ln w="4445">
             <a:solidFill>
@@ -31580,7 +31580,7 @@
             <a:avLst/>
           </a:prstGeom>
           <a:solidFill>
-            <a:srgbClr val="C53E1F"/>
+            <a:srgbClr val="6C757D"/>
           </a:solidFill>
           <a:ln w="4445">
             <a:solidFill>
@@ -31626,7 +31626,7 @@
             <a:avLst/>
           </a:prstGeom>
           <a:solidFill>
-            <a:srgbClr val="C53E1F"/>
+            <a:srgbClr val="6C757D"/>
           </a:solidFill>
           <a:ln w="4445">
             <a:solidFill>
@@ -31672,7 +31672,7 @@
             <a:avLst/>
           </a:prstGeom>
           <a:solidFill>
-            <a:srgbClr val="C53E1F"/>
+            <a:srgbClr val="6C757D"/>
           </a:solidFill>
           <a:ln w="4445">
             <a:solidFill>
@@ -31718,7 +31718,7 @@
             <a:avLst/>
           </a:prstGeom>
           <a:solidFill>
-            <a:srgbClr val="0A7D6E"/>
+            <a:srgbClr val="6C757D"/>
           </a:solidFill>
           <a:ln w="4445">
             <a:solidFill>
@@ -31764,7 +31764,7 @@
             <a:avLst/>
           </a:prstGeom>
           <a:solidFill>
-            <a:srgbClr val="0A7D6E"/>
+            <a:srgbClr val="6C757D"/>
           </a:solidFill>
           <a:ln w="4445">
             <a:solidFill>
@@ -31810,7 +31810,7 @@
             <a:avLst/>
           </a:prstGeom>
           <a:solidFill>
-            <a:srgbClr val="C53E1F"/>
+            <a:srgbClr val="6C757D"/>
           </a:solidFill>
           <a:ln w="4445">
             <a:solidFill>
@@ -31856,7 +31856,7 @@
             <a:avLst/>
           </a:prstGeom>
           <a:solidFill>
-            <a:srgbClr val="C53E1F"/>
+            <a:srgbClr val="6C757D"/>
           </a:solidFill>
           <a:ln w="4445">
             <a:solidFill>
@@ -31902,7 +31902,7 @@
             <a:avLst/>
           </a:prstGeom>
           <a:solidFill>
-            <a:srgbClr val="C53E1F"/>
+            <a:srgbClr val="6C757D"/>
           </a:solidFill>
           <a:ln w="4445">
             <a:solidFill>
@@ -31948,7 +31948,7 @@
             <a:avLst/>
           </a:prstGeom>
           <a:solidFill>
-            <a:srgbClr val="C53E1F"/>
+            <a:srgbClr val="6C757D"/>
           </a:solidFill>
           <a:ln w="4445">
             <a:solidFill>
@@ -31994,7 +31994,7 @@
             <a:avLst/>
           </a:prstGeom>
           <a:solidFill>
-            <a:srgbClr val="0A7D6E"/>
+            <a:srgbClr val="6C757D"/>
           </a:solidFill>
           <a:ln w="4445">
             <a:solidFill>
@@ -32040,7 +32040,7 @@
             <a:avLst/>
           </a:prstGeom>
           <a:solidFill>
-            <a:srgbClr val="C53E1F"/>
+            <a:srgbClr val="6C757D"/>
           </a:solidFill>
           <a:ln w="4445">
             <a:solidFill>
@@ -32086,7 +32086,7 @@
             <a:avLst/>
           </a:prstGeom>
           <a:solidFill>
-            <a:srgbClr val="C53E1F"/>
+            <a:srgbClr val="6C757D"/>
           </a:solidFill>
           <a:ln w="4445">
             <a:solidFill>
@@ -32132,7 +32132,7 @@
             <a:avLst/>
           </a:prstGeom>
           <a:solidFill>
-            <a:srgbClr val="0A7D6E"/>
+            <a:srgbClr val="6C757D"/>
           </a:solidFill>
           <a:ln w="4445">
             <a:solidFill>
@@ -32178,7 +32178,7 @@
             <a:avLst/>
           </a:prstGeom>
           <a:solidFill>
-            <a:srgbClr val="C53E1F"/>
+            <a:srgbClr val="6C757D"/>
           </a:solidFill>
           <a:ln w="4445">
             <a:solidFill>
@@ -32224,7 +32224,7 @@
             <a:avLst/>
           </a:prstGeom>
           <a:solidFill>
-            <a:srgbClr val="C53E1F"/>
+            <a:srgbClr val="6C757D"/>
           </a:solidFill>
           <a:ln w="4445">
             <a:solidFill>
@@ -32270,7 +32270,7 @@
             <a:avLst/>
           </a:prstGeom>
           <a:solidFill>
-            <a:srgbClr val="0A7D6E"/>
+            <a:srgbClr val="6C757D"/>
           </a:solidFill>
           <a:ln w="4445">
             <a:solidFill>
@@ -32316,7 +32316,7 @@
             <a:avLst/>
           </a:prstGeom>
           <a:solidFill>
-            <a:srgbClr val="0A7D6E"/>
+            <a:srgbClr val="6C757D"/>
           </a:solidFill>
           <a:ln w="4445">
             <a:solidFill>
@@ -32362,7 +32362,7 @@
             <a:avLst/>
           </a:prstGeom>
           <a:solidFill>
-            <a:srgbClr val="C53E1F"/>
+            <a:srgbClr val="6C757D"/>
           </a:solidFill>
           <a:ln w="4445">
             <a:solidFill>
@@ -32408,7 +32408,7 @@
             <a:avLst/>
           </a:prstGeom>
           <a:solidFill>
-            <a:srgbClr val="C53E1F"/>
+            <a:srgbClr val="6C757D"/>
           </a:solidFill>
           <a:ln w="4445">
             <a:solidFill>
@@ -32454,7 +32454,7 @@
             <a:avLst/>
           </a:prstGeom>
           <a:solidFill>
-            <a:srgbClr val="0A7D6E"/>
+            <a:srgbClr val="6C757D"/>
           </a:solidFill>
           <a:ln w="4445">
             <a:solidFill>
@@ -32500,7 +32500,7 @@
             <a:avLst/>
           </a:prstGeom>
           <a:solidFill>
-            <a:srgbClr val="0A7D6E"/>
+            <a:srgbClr val="6C757D"/>
           </a:solidFill>
           <a:ln w="4445">
             <a:solidFill>
@@ -32546,7 +32546,7 @@
             <a:avLst/>
           </a:prstGeom>
           <a:solidFill>
-            <a:srgbClr val="0A7D6E"/>
+            <a:srgbClr val="6C757D"/>
           </a:solidFill>
           <a:ln w="4445">
             <a:solidFill>
@@ -32592,7 +32592,7 @@
             <a:avLst/>
           </a:prstGeom>
           <a:solidFill>
-            <a:srgbClr val="0A7D6E"/>
+            <a:srgbClr val="6C757D"/>
           </a:solidFill>
           <a:ln w="4445">
             <a:solidFill>
@@ -32638,7 +32638,7 @@
             <a:avLst/>
           </a:prstGeom>
           <a:solidFill>
-            <a:srgbClr val="C53E1F"/>
+            <a:srgbClr val="6C757D"/>
           </a:solidFill>
           <a:ln w="4445">
             <a:solidFill>
@@ -32684,7 +32684,7 @@
             <a:avLst/>
           </a:prstGeom>
           <a:solidFill>
-            <a:srgbClr val="0A7D6E"/>
+            <a:srgbClr val="6C757D"/>
           </a:solidFill>
           <a:ln w="4445">
             <a:solidFill>
@@ -32730,7 +32730,7 @@
             <a:avLst/>
           </a:prstGeom>
           <a:solidFill>
-            <a:srgbClr val="0A7D6E"/>
+            <a:srgbClr val="6C757D"/>
           </a:solidFill>
           <a:ln w="4445">
             <a:solidFill>
@@ -32776,7 +32776,7 @@
             <a:avLst/>
           </a:prstGeom>
           <a:solidFill>
-            <a:srgbClr val="0A7D6E"/>
+            <a:srgbClr val="6C757D"/>
           </a:solidFill>
           <a:ln w="4445">
             <a:solidFill>
@@ -32822,7 +32822,7 @@
             <a:avLst/>
           </a:prstGeom>
           <a:solidFill>
-            <a:srgbClr val="C53E1F"/>
+            <a:srgbClr val="6C757D"/>
           </a:solidFill>
           <a:ln w="4445">
             <a:solidFill>
@@ -32868,7 +32868,7 @@
             <a:avLst/>
           </a:prstGeom>
           <a:solidFill>
-            <a:srgbClr val="0A7D6E"/>
+            <a:srgbClr val="6C757D"/>
           </a:solidFill>
           <a:ln w="4445">
             <a:solidFill>
@@ -32914,7 +32914,7 @@
             <a:avLst/>
           </a:prstGeom>
           <a:solidFill>
-            <a:srgbClr val="0A7D6E"/>
+            <a:srgbClr val="6C757D"/>
           </a:solidFill>
           <a:ln w="4445">
             <a:solidFill>
@@ -32960,7 +32960,7 @@
             <a:avLst/>
           </a:prstGeom>
           <a:solidFill>
-            <a:srgbClr val="0A7D6E"/>
+            <a:srgbClr val="6C757D"/>
           </a:solidFill>
           <a:ln w="4445">
             <a:solidFill>
@@ -33006,7 +33006,7 @@
             <a:avLst/>
           </a:prstGeom>
           <a:solidFill>
-            <a:srgbClr val="0A7D6E"/>
+            <a:srgbClr val="6C757D"/>
           </a:solidFill>
           <a:ln w="4445">
             <a:solidFill>
@@ -33052,7 +33052,7 @@
             <a:avLst/>
           </a:prstGeom>
           <a:solidFill>
-            <a:srgbClr val="C53E1F"/>
+            <a:srgbClr val="6C757D"/>
           </a:solidFill>
           <a:ln w="4445">
             <a:solidFill>
@@ -33098,7 +33098,7 @@
             <a:avLst/>
           </a:prstGeom>
           <a:solidFill>
-            <a:srgbClr val="C53E1F"/>
+            <a:srgbClr val="6C757D"/>
           </a:solidFill>
           <a:ln w="4445">
             <a:solidFill>
@@ -33144,7 +33144,7 @@
             <a:avLst/>
           </a:prstGeom>
           <a:solidFill>
-            <a:srgbClr val="0A7D6E"/>
+            <a:srgbClr val="6C757D"/>
           </a:solidFill>
           <a:ln w="4445">
             <a:solidFill>
@@ -33190,7 +33190,7 @@
             <a:avLst/>
           </a:prstGeom>
           <a:solidFill>
-            <a:srgbClr val="C53E1F"/>
+            <a:srgbClr val="6C757D"/>
           </a:solidFill>
           <a:ln w="4445">
             <a:solidFill>
@@ -33236,7 +33236,7 @@
             <a:avLst/>
           </a:prstGeom>
           <a:solidFill>
-            <a:srgbClr val="C53E1F"/>
+            <a:srgbClr val="6C757D"/>
           </a:solidFill>
           <a:ln w="4445">
             <a:solidFill>
@@ -33282,7 +33282,7 @@
             <a:avLst/>
           </a:prstGeom>
           <a:solidFill>
-            <a:srgbClr val="0A7D6E"/>
+            <a:srgbClr val="6C757D"/>
           </a:solidFill>
           <a:ln w="4445">
             <a:solidFill>
@@ -33328,7 +33328,7 @@
             <a:avLst/>
           </a:prstGeom>
           <a:solidFill>
-            <a:srgbClr val="C53E1F"/>
+            <a:srgbClr val="6C757D"/>
           </a:solidFill>
           <a:ln w="4445">
             <a:solidFill>
@@ -33374,7 +33374,7 @@
             <a:avLst/>
           </a:prstGeom>
           <a:solidFill>
-            <a:srgbClr val="0A7D6E"/>
+            <a:srgbClr val="6C757D"/>
           </a:solidFill>
           <a:ln w="4445">
             <a:solidFill>
@@ -33420,7 +33420,7 @@
             <a:avLst/>
           </a:prstGeom>
           <a:solidFill>
-            <a:srgbClr val="0A7D6E"/>
+            <a:srgbClr val="6C757D"/>
           </a:solidFill>
           <a:ln w="4445">
             <a:solidFill>
@@ -33466,7 +33466,7 @@
             <a:avLst/>
           </a:prstGeom>
           <a:solidFill>
-            <a:srgbClr val="C53E1F"/>
+            <a:srgbClr val="6C757D"/>
           </a:solidFill>
           <a:ln w="4445">
             <a:solidFill>
@@ -33512,7 +33512,7 @@
             <a:avLst/>
           </a:prstGeom>
           <a:solidFill>
-            <a:srgbClr val="0A7D6E"/>
+            <a:srgbClr val="6C757D"/>
           </a:solidFill>
           <a:ln w="4445">
             <a:solidFill>
@@ -33558,7 +33558,7 @@
             <a:avLst/>
           </a:prstGeom>
           <a:solidFill>
-            <a:srgbClr val="0A7D6E"/>
+            <a:srgbClr val="6C757D"/>
           </a:solidFill>
           <a:ln w="4445">
             <a:solidFill>
@@ -33604,7 +33604,7 @@
             <a:avLst/>
           </a:prstGeom>
           <a:solidFill>
-            <a:srgbClr val="C53E1F"/>
+            <a:srgbClr val="6C757D"/>
           </a:solidFill>
           <a:ln w="4445">
             <a:solidFill>
@@ -33650,7 +33650,7 @@
             <a:avLst/>
           </a:prstGeom>
           <a:solidFill>
-            <a:srgbClr val="C53E1F"/>
+            <a:srgbClr val="6C757D"/>
           </a:solidFill>
           <a:ln w="4445">
             <a:solidFill>
@@ -33696,7 +33696,7 @@
             <a:avLst/>
           </a:prstGeom>
           <a:solidFill>
-            <a:srgbClr val="C53E1F"/>
+            <a:srgbClr val="6C757D"/>
           </a:solidFill>
           <a:ln w="4445">
             <a:solidFill>
@@ -33742,7 +33742,7 @@
             <a:avLst/>
           </a:prstGeom>
           <a:solidFill>
-            <a:srgbClr val="0A7D6E"/>
+            <a:srgbClr val="6C757D"/>
           </a:solidFill>
           <a:ln w="4445">
             <a:solidFill>
@@ -33788,7 +33788,7 @@
             <a:avLst/>
           </a:prstGeom>
           <a:solidFill>
-            <a:srgbClr val="C53E1F"/>
+            <a:srgbClr val="6C757D"/>
           </a:solidFill>
           <a:ln w="4445">
             <a:solidFill>
@@ -33834,7 +33834,7 @@
             <a:avLst/>
           </a:prstGeom>
           <a:solidFill>
-            <a:srgbClr val="0A7D6E"/>
+            <a:srgbClr val="6C757D"/>
           </a:solidFill>
           <a:ln w="4445">
             <a:solidFill>
@@ -33880,7 +33880,7 @@
             <a:avLst/>
           </a:prstGeom>
           <a:solidFill>
-            <a:srgbClr val="C53E1F"/>
+            <a:srgbClr val="6C757D"/>
           </a:solidFill>
           <a:ln w="4445">
             <a:solidFill>
@@ -33926,7 +33926,7 @@
             <a:avLst/>
           </a:prstGeom>
           <a:solidFill>
-            <a:srgbClr val="0A7D6E"/>
+            <a:srgbClr val="6C757D"/>
           </a:solidFill>
           <a:ln w="4445">
             <a:solidFill>
@@ -33972,7 +33972,7 @@
             <a:avLst/>
           </a:prstGeom>
           <a:solidFill>
-            <a:srgbClr val="0A7D6E"/>
+            <a:srgbClr val="6C757D"/>
           </a:solidFill>
           <a:ln w="4445">
             <a:solidFill>
@@ -34018,7 +34018,7 @@
             <a:avLst/>
           </a:prstGeom>
           <a:solidFill>
-            <a:srgbClr val="C53E1F"/>
+            <a:srgbClr val="6C757D"/>
           </a:solidFill>
           <a:ln w="4445">
             <a:solidFill>
@@ -34064,7 +34064,7 @@
             <a:avLst/>
           </a:prstGeom>
           <a:solidFill>
-            <a:srgbClr val="C53E1F"/>
+            <a:srgbClr val="6C757D"/>
           </a:solidFill>
           <a:ln w="4445">
             <a:solidFill>
@@ -34110,7 +34110,7 @@
             <a:avLst/>
           </a:prstGeom>
           <a:solidFill>
-            <a:srgbClr val="0A7D6E"/>
+            <a:srgbClr val="6C757D"/>
           </a:solidFill>
           <a:ln w="4445">
             <a:solidFill>
@@ -34156,7 +34156,7 @@
             <a:avLst/>
           </a:prstGeom>
           <a:solidFill>
-            <a:srgbClr val="0A7D6E"/>
+            <a:srgbClr val="6C757D"/>
           </a:solidFill>
           <a:ln w="4445">
             <a:solidFill>
@@ -34202,7 +34202,7 @@
             <a:avLst/>
           </a:prstGeom>
           <a:solidFill>
-            <a:srgbClr val="0A7D6E"/>
+            <a:srgbClr val="6C757D"/>
           </a:solidFill>
           <a:ln w="4445">
             <a:solidFill>
@@ -34248,7 +34248,7 @@
             <a:avLst/>
           </a:prstGeom>
           <a:solidFill>
-            <a:srgbClr val="C53E1F"/>
+            <a:srgbClr val="6C757D"/>
           </a:solidFill>
           <a:ln w="4445">
             <a:solidFill>
@@ -34294,7 +34294,7 @@
             <a:avLst/>
           </a:prstGeom>
           <a:solidFill>
-            <a:srgbClr val="0A7D6E"/>
+            <a:srgbClr val="6C757D"/>
           </a:solidFill>
           <a:ln w="4445">
             <a:solidFill>
@@ -34340,7 +34340,7 @@
             <a:avLst/>
           </a:prstGeom>
           <a:solidFill>
-            <a:srgbClr val="0A7D6E"/>
+            <a:srgbClr val="6C757D"/>
           </a:solidFill>
           <a:ln w="4445">
             <a:solidFill>
@@ -34386,7 +34386,7 @@
             <a:avLst/>
           </a:prstGeom>
           <a:solidFill>
-            <a:srgbClr val="0A7D6E"/>
+            <a:srgbClr val="6C757D"/>
           </a:solidFill>
           <a:ln w="4445">
             <a:solidFill>
@@ -34432,7 +34432,7 @@
             <a:avLst/>
           </a:prstGeom>
           <a:solidFill>
-            <a:srgbClr val="C53E1F"/>
+            <a:srgbClr val="6C757D"/>
           </a:solidFill>
           <a:ln w="4445">
             <a:solidFill>
@@ -34478,7 +34478,7 @@
             <a:avLst/>
           </a:prstGeom>
           <a:solidFill>
-            <a:srgbClr val="0A7D6E"/>
+            <a:srgbClr val="6C757D"/>
           </a:solidFill>
           <a:ln w="4445">
             <a:solidFill>
@@ -34524,7 +34524,7 @@
             <a:avLst/>
           </a:prstGeom>
           <a:solidFill>
-            <a:srgbClr val="0A7D6E"/>
+            <a:srgbClr val="6C757D"/>
           </a:solidFill>
           <a:ln w="4445">
             <a:solidFill>
@@ -34570,7 +34570,7 @@
             <a:avLst/>
           </a:prstGeom>
           <a:solidFill>
-            <a:srgbClr val="0A7D6E"/>
+            <a:srgbClr val="6C757D"/>
           </a:solidFill>
           <a:ln w="4445">
             <a:solidFill>
@@ -34616,7 +34616,7 @@
             <a:avLst/>
           </a:prstGeom>
           <a:solidFill>
-            <a:srgbClr val="0A7D6E"/>
+            <a:srgbClr val="6C757D"/>
           </a:solidFill>
           <a:ln w="4445">
             <a:solidFill>
@@ -34662,7 +34662,7 @@
             <a:avLst/>
           </a:prstGeom>
           <a:solidFill>
-            <a:srgbClr val="0A7D6E"/>
+            <a:srgbClr val="6C757D"/>
           </a:solidFill>
           <a:ln w="4445">
             <a:solidFill>
@@ -34708,7 +34708,7 @@
             <a:avLst/>
           </a:prstGeom>
           <a:solidFill>
-            <a:srgbClr val="C53E1F"/>
+            <a:srgbClr val="6C757D"/>
           </a:solidFill>
           <a:ln w="4445">
             <a:solidFill>
@@ -34754,7 +34754,7 @@
             <a:avLst/>
           </a:prstGeom>
           <a:solidFill>
-            <a:srgbClr val="C53E1F"/>
+            <a:srgbClr val="6C757D"/>
           </a:solidFill>
           <a:ln w="4445">
             <a:solidFill>
@@ -34800,7 +34800,7 @@
             <a:avLst/>
           </a:prstGeom>
           <a:solidFill>
-            <a:srgbClr val="0A7D6E"/>
+            <a:srgbClr val="6C757D"/>
           </a:solidFill>
           <a:ln w="4445">
             <a:solidFill>
@@ -34846,7 +34846,7 @@
             <a:avLst/>
           </a:prstGeom>
           <a:solidFill>
-            <a:srgbClr val="C53E1F"/>
+            <a:srgbClr val="6C757D"/>
           </a:solidFill>
           <a:ln w="4445">
             <a:solidFill>
@@ -34892,7 +34892,7 @@
             <a:avLst/>
           </a:prstGeom>
           <a:solidFill>
-            <a:srgbClr val="C53E1F"/>
+            <a:srgbClr val="6C757D"/>
           </a:solidFill>
           <a:ln w="4445">
             <a:solidFill>
@@ -34938,7 +34938,7 @@
             <a:avLst/>
           </a:prstGeom>
           <a:solidFill>
-            <a:srgbClr val="C53E1F"/>
+            <a:srgbClr val="6C757D"/>
           </a:solidFill>
           <a:ln w="4445">
             <a:solidFill>
@@ -34984,7 +34984,7 @@
             <a:avLst/>
           </a:prstGeom>
           <a:solidFill>
-            <a:srgbClr val="C53E1F"/>
+            <a:srgbClr val="6C757D"/>
           </a:solidFill>
           <a:ln w="4445">
             <a:solidFill>
@@ -35030,7 +35030,7 @@
             <a:avLst/>
           </a:prstGeom>
           <a:solidFill>
-            <a:srgbClr val="C53E1F"/>
+            <a:srgbClr val="6C757D"/>
           </a:solidFill>
           <a:ln w="4445">
             <a:solidFill>
@@ -35076,7 +35076,7 @@
             <a:avLst/>
           </a:prstGeom>
           <a:solidFill>
-            <a:srgbClr val="C53E1F"/>
+            <a:srgbClr val="6C757D"/>
           </a:solidFill>
           <a:ln w="4445">
             <a:solidFill>
@@ -35122,7 +35122,7 @@
             <a:avLst/>
           </a:prstGeom>
           <a:solidFill>
-            <a:srgbClr val="C53E1F"/>
+            <a:srgbClr val="6C757D"/>
           </a:solidFill>
           <a:ln w="4445">
             <a:solidFill>
@@ -35168,7 +35168,7 @@
             <a:avLst/>
           </a:prstGeom>
           <a:solidFill>
-            <a:srgbClr val="C53E1F"/>
+            <a:srgbClr val="6C757D"/>
           </a:solidFill>
           <a:ln w="4445">
             <a:solidFill>
@@ -35214,7 +35214,7 @@
             <a:avLst/>
           </a:prstGeom>
           <a:solidFill>
-            <a:srgbClr val="0A7D6E"/>
+            <a:srgbClr val="6C757D"/>
           </a:solidFill>
           <a:ln w="4445">
             <a:solidFill>
@@ -35260,7 +35260,7 @@
             <a:avLst/>
           </a:prstGeom>
           <a:solidFill>
-            <a:srgbClr val="C53E1F"/>
+            <a:srgbClr val="6C757D"/>
           </a:solidFill>
           <a:ln w="4445">
             <a:solidFill>
@@ -35306,7 +35306,7 @@
             <a:avLst/>
           </a:prstGeom>
           <a:solidFill>
-            <a:srgbClr val="0A7D6E"/>
+            <a:srgbClr val="6C757D"/>
           </a:solidFill>
           <a:ln w="4445">
             <a:solidFill>
@@ -35352,7 +35352,7 @@
             <a:avLst/>
           </a:prstGeom>
           <a:solidFill>
-            <a:srgbClr val="0A7D6E"/>
+            <a:srgbClr val="6C757D"/>
           </a:solidFill>
           <a:ln w="4445">
             <a:solidFill>
@@ -35398,7 +35398,7 @@
             <a:avLst/>
           </a:prstGeom>
           <a:solidFill>
-            <a:srgbClr val="C53E1F"/>
+            <a:srgbClr val="6C757D"/>
           </a:solidFill>
           <a:ln w="4445">
             <a:solidFill>
@@ -35444,7 +35444,7 @@
             <a:avLst/>
           </a:prstGeom>
           <a:solidFill>
-            <a:srgbClr val="C53E1F"/>
+            <a:srgbClr val="6C757D"/>
           </a:solidFill>
           <a:ln w="4445">
             <a:solidFill>
@@ -35490,7 +35490,7 @@
             <a:avLst/>
           </a:prstGeom>
           <a:solidFill>
-            <a:srgbClr val="0A7D6E"/>
+            <a:srgbClr val="6C757D"/>
           </a:solidFill>
           <a:ln w="4445">
             <a:solidFill>
@@ -35536,7 +35536,7 @@
             <a:avLst/>
           </a:prstGeom>
           <a:solidFill>
-            <a:srgbClr val="C53E1F"/>
+            <a:srgbClr val="6C757D"/>
           </a:solidFill>
           <a:ln w="4445">
             <a:solidFill>
@@ -35582,7 +35582,7 @@
             <a:avLst/>
           </a:prstGeom>
           <a:solidFill>
-            <a:srgbClr val="0A7D6E"/>
+            <a:srgbClr val="6C757D"/>
           </a:solidFill>
           <a:ln w="4445">
             <a:solidFill>
@@ -35628,7 +35628,7 @@
             <a:avLst/>
           </a:prstGeom>
           <a:solidFill>
-            <a:srgbClr val="C53E1F"/>
+            <a:srgbClr val="6C757D"/>
           </a:solidFill>
           <a:ln w="4445">
             <a:solidFill>
@@ -35674,7 +35674,7 @@
             <a:avLst/>
           </a:prstGeom>
           <a:solidFill>
-            <a:srgbClr val="C53E1F"/>
+            <a:srgbClr val="6C757D"/>
           </a:solidFill>
           <a:ln w="4445">
             <a:solidFill>
@@ -35720,7 +35720,7 @@
             <a:avLst/>
           </a:prstGeom>
           <a:solidFill>
-            <a:srgbClr val="C53E1F"/>
+            <a:srgbClr val="6C757D"/>
           </a:solidFill>
           <a:ln w="4445">
             <a:solidFill>
@@ -35766,7 +35766,7 @@
             <a:avLst/>
           </a:prstGeom>
           <a:solidFill>
-            <a:srgbClr val="0A7D6E"/>
+            <a:srgbClr val="6C757D"/>
           </a:solidFill>
           <a:ln w="4445">
             <a:solidFill>
@@ -35812,7 +35812,7 @@
             <a:avLst/>
           </a:prstGeom>
           <a:solidFill>
-            <a:srgbClr val="0A7D6E"/>
+            <a:srgbClr val="6C757D"/>
           </a:solidFill>
           <a:ln w="4445">
             <a:solidFill>
@@ -35858,7 +35858,7 @@
             <a:avLst/>
           </a:prstGeom>
           <a:solidFill>
-            <a:srgbClr val="C53E1F"/>
+            <a:srgbClr val="6C757D"/>
           </a:solidFill>
           <a:ln w="4445">
             <a:solidFill>
@@ -35904,7 +35904,7 @@
             <a:avLst/>
           </a:prstGeom>
           <a:solidFill>
-            <a:srgbClr val="0A7D6E"/>
+            <a:srgbClr val="6C757D"/>
           </a:solidFill>
           <a:ln w="4445">
             <a:solidFill>
@@ -35950,7 +35950,7 @@
             <a:avLst/>
           </a:prstGeom>
           <a:solidFill>
-            <a:srgbClr val="0A7D6E"/>
+            <a:srgbClr val="6C757D"/>
           </a:solidFill>
           <a:ln w="4445">
             <a:solidFill>
@@ -35996,7 +35996,7 @@
             <a:avLst/>
           </a:prstGeom>
           <a:solidFill>
-            <a:srgbClr val="0A7D6E"/>
+            <a:srgbClr val="6C757D"/>
           </a:solidFill>
           <a:ln w="4445">
             <a:solidFill>
@@ -36042,7 +36042,7 @@
             <a:avLst/>
           </a:prstGeom>
           <a:solidFill>
-            <a:srgbClr val="C53E1F"/>
+            <a:srgbClr val="6C757D"/>
           </a:solidFill>
           <a:ln w="4445">
             <a:solidFill>
@@ -36088,7 +36088,7 @@
             <a:avLst/>
           </a:prstGeom>
           <a:solidFill>
-            <a:srgbClr val="0A7D6E"/>
+            <a:srgbClr val="6C757D"/>
           </a:solidFill>
           <a:ln w="4445">
             <a:solidFill>
@@ -36134,7 +36134,7 @@
             <a:avLst/>
           </a:prstGeom>
           <a:solidFill>
-            <a:srgbClr val="C53E1F"/>
+            <a:srgbClr val="6C757D"/>
           </a:solidFill>
           <a:ln w="4445">
             <a:solidFill>
@@ -36180,7 +36180,7 @@
             <a:avLst/>
           </a:prstGeom>
           <a:solidFill>
-            <a:srgbClr val="0A7D6E"/>
+            <a:srgbClr val="6C757D"/>
           </a:solidFill>
           <a:ln w="4445">
             <a:solidFill>
@@ -36226,7 +36226,7 @@
             <a:avLst/>
           </a:prstGeom>
           <a:solidFill>
-            <a:srgbClr val="C53E1F"/>
+            <a:srgbClr val="6C757D"/>
           </a:solidFill>
           <a:ln w="4445">
             <a:solidFill>
@@ -37836,7 +37836,7 @@
             <a:r>
               <a:rPr sz="700" b="1" i="0">
                 <a:solidFill>
-                  <a:srgbClr val="C53E1F"/>
+                  <a:srgbClr val="6C757D"/>
                 </a:solidFill>
                 <a:latin typeface="Arial"/>
               </a:rPr>
@@ -37872,7 +37872,7 @@
             <a:r>
               <a:rPr sz="700" b="1" i="0">
                 <a:solidFill>
-                  <a:srgbClr val="0A7D6E"/>
+                  <a:srgbClr val="6C757D"/>
                 </a:solidFill>
                 <a:latin typeface="Arial"/>
               </a:rPr>
@@ -37908,7 +37908,7 @@
             <a:r>
               <a:rPr sz="700" b="1" i="0">
                 <a:solidFill>
-                  <a:srgbClr val="0A7D6E"/>
+                  <a:srgbClr val="6C757D"/>
                 </a:solidFill>
                 <a:latin typeface="Arial"/>
               </a:rPr>
@@ -37944,7 +37944,7 @@
             <a:r>
               <a:rPr sz="700" b="1" i="0">
                 <a:solidFill>
-                  <a:srgbClr val="0A7D6E"/>
+                  <a:srgbClr val="6C757D"/>
                 </a:solidFill>
                 <a:latin typeface="Arial"/>
               </a:rPr>
@@ -37980,7 +37980,7 @@
             <a:r>
               <a:rPr sz="700" b="1" i="0">
                 <a:solidFill>
-                  <a:srgbClr val="0A7D6E"/>
+                  <a:srgbClr val="6C757D"/>
                 </a:solidFill>
                 <a:latin typeface="Arial"/>
               </a:rPr>
@@ -38016,7 +38016,7 @@
             <a:r>
               <a:rPr sz="700" b="1" i="0">
                 <a:solidFill>
-                  <a:srgbClr val="C53E1F"/>
+                  <a:srgbClr val="6C757D"/>
                 </a:solidFill>
                 <a:latin typeface="Arial"/>
               </a:rPr>
@@ -38052,7 +38052,7 @@
             <a:r>
               <a:rPr sz="700" b="1" i="0">
                 <a:solidFill>
-                  <a:srgbClr val="C53E1F"/>
+                  <a:srgbClr val="6C757D"/>
                 </a:solidFill>
                 <a:latin typeface="Arial"/>
               </a:rPr>
@@ -38088,7 +38088,7 @@
             <a:r>
               <a:rPr sz="700" b="1" i="0">
                 <a:solidFill>
-                  <a:srgbClr val="0A7D6E"/>
+                  <a:srgbClr val="6C757D"/>
                 </a:solidFill>
                 <a:latin typeface="Arial"/>
               </a:rPr>
@@ -38124,7 +38124,7 @@
             <a:r>
               <a:rPr sz="700" b="1" i="0">
                 <a:solidFill>
-                  <a:srgbClr val="0A7D6E"/>
+                  <a:srgbClr val="6C757D"/>
                 </a:solidFill>
                 <a:latin typeface="Arial"/>
               </a:rPr>
@@ -38160,7 +38160,7 @@
             <a:r>
               <a:rPr sz="700" b="1" i="0">
                 <a:solidFill>
-                  <a:srgbClr val="0A7D6E"/>
+                  <a:srgbClr val="6C757D"/>
                 </a:solidFill>
                 <a:latin typeface="Arial"/>
               </a:rPr>
@@ -38744,7 +38744,7 @@
             <a:avLst/>
           </a:prstGeom>
           <a:solidFill>
-            <a:srgbClr val="0A7D6E"/>
+            <a:srgbClr val="6C757D"/>
           </a:solidFill>
           <a:ln w="3810">
             <a:solidFill>
@@ -38806,7 +38806,7 @@
                 </a:solidFill>
                 <a:latin typeface="Arial"/>
               </a:rPr>
-              <a:t>Other, up-good  (n = 106)</a:t>
+              <a:t>Other (no pathway)  (n = 206)</a:t>
             </a:r>
           </a:p>
         </p:txBody>
@@ -38819,14 +38819,14 @@
         </p:nvSpPr>
         <p:spPr>
           <a:xfrm>
-            <a:off x="5753960" y="5564984"/>
-            <a:ext cx="44000" cy="44000"/>
-          </a:xfrm>
-          <a:prstGeom prst="ellipse">
-            <a:avLst/>
-          </a:prstGeom>
-          <a:solidFill>
-            <a:srgbClr val="C53E1F"/>
+            <a:off x="5757960" y="5568984"/>
+            <a:ext cx="36000" cy="36000"/>
+          </a:xfrm>
+          <a:prstGeom prst="ellipse">
+            <a:avLst/>
+          </a:prstGeom>
+          <a:solidFill>
+            <a:srgbClr val="DDE2E8"/>
           </a:solidFill>
           <a:ln w="3810">
             <a:solidFill>
@@ -38866,88 +38866,6 @@
         <p:spPr>
           <a:xfrm>
             <a:off x="5913120" y="5504688"/>
-            <a:ext cx="1950720" cy="164592"/>
-          </a:xfrm>
-          <a:prstGeom prst="rect">
-            <a:avLst/>
-          </a:prstGeom>
-          <a:noFill/>
-          <a:effectLst/>
-        </p:spPr>
-        <p:txBody>
-          <a:bodyPr wrap="square" lIns="0" rIns="0" tIns="0" bIns="0" anchor="ctr">
-            <a:spAutoFit/>
-          </a:bodyPr>
-          <a:lstStyle/>
-          <a:p>
-            <a:pPr algn="l"/>
-            <a:r>
-              <a:rPr sz="750" b="0" i="0">
-                <a:solidFill>
-                  <a:srgbClr val="0E2A47"/>
-                </a:solidFill>
-                <a:latin typeface="Arial"/>
-              </a:rPr>
-              <a:t>Other, up-poor  (n = 100)</a:t>
-            </a:r>
-          </a:p>
-        </p:txBody>
-      </p:sp>
-      <p:sp>
-        <p:nvSpPr>
-          <p:cNvPr id="820" name="Oval 819"/>
-          <p:cNvSpPr/>
-          <p:nvPr/>
-        </p:nvSpPr>
-        <p:spPr>
-          <a:xfrm>
-            <a:off x="1307880" y="5815872"/>
-            <a:ext cx="36000" cy="36000"/>
-          </a:xfrm>
-          <a:prstGeom prst="ellipse">
-            <a:avLst/>
-          </a:prstGeom>
-          <a:solidFill>
-            <a:srgbClr val="DDE2E8"/>
-          </a:solidFill>
-          <a:ln w="3810">
-            <a:solidFill>
-              <a:srgbClr val="0E2A47"/>
-            </a:solidFill>
-          </a:ln>
-          <a:effectLst/>
-        </p:spPr>
-        <p:style>
-          <a:lnRef idx="1">
-            <a:schemeClr val="accent1"/>
-          </a:lnRef>
-          <a:fillRef idx="3">
-            <a:schemeClr val="accent1"/>
-          </a:fillRef>
-          <a:effectRef idx="2">
-            <a:schemeClr val="accent1"/>
-          </a:effectRef>
-          <a:fontRef idx="minor">
-            <a:schemeClr val="lt1"/>
-          </a:fontRef>
-        </p:style>
-        <p:txBody>
-          <a:bodyPr rtlCol="0" anchor="ctr"/>
-          <a:lstStyle/>
-          <a:p>
-            <a:pPr algn="ctr"/>
-          </a:p>
-        </p:txBody>
-      </p:sp>
-      <p:sp>
-        <p:nvSpPr>
-          <p:cNvPr id="821" name="TextBox 820"/>
-          <p:cNvSpPr txBox="1"/>
-          <p:nvPr/>
-        </p:nvSpPr>
-        <p:spPr>
-          <a:xfrm>
-            <a:off x="1463040" y="5751576"/>
             <a:ext cx="1950720" cy="164592"/>
           </a:xfrm>
           <a:prstGeom prst="rect">

</xml_diff>